<commit_message>
docs: simplify SIH 6-slide pptx deck for higher readability
</commit_message>
<xml_diff>
--- a/Employee_Leave_Management_System_SIH.pptx
+++ b/Employee_Leave_Management_System_SIH.pptx
@@ -3102,13 +3102,13 @@
         <p:spPr>
           <a:xfrm>
             <a:off x="0" y="0"/>
-            <a:ext cx="365760" cy="6858000"/>
+            <a:ext cx="320040" cy="6858000"/>
           </a:xfrm>
           <a:prstGeom prst="rect">
             <a:avLst/>
           </a:prstGeom>
           <a:solidFill>
-            <a:srgbClr val="0F766E"/>
+            <a:srgbClr val="0E7490"/>
           </a:solidFill>
           <a:ln>
             <a:noFill/>
@@ -3144,8 +3144,8 @@
         </p:nvSpPr>
         <p:spPr>
           <a:xfrm>
-            <a:off x="1097280" y="731520"/>
-            <a:ext cx="4114800" cy="411480"/>
+            <a:off x="914400" y="731520"/>
+            <a:ext cx="3291840" cy="365760"/>
           </a:xfrm>
           <a:prstGeom prst="roundRect">
             <a:avLst/>
@@ -3155,7 +3155,7 @@
           </a:solidFill>
           <a:ln>
             <a:solidFill>
-              <a:srgbClr val="0F766E"/>
+              <a:srgbClr val="0E7490"/>
             </a:solidFill>
           </a:ln>
         </p:spPr>
@@ -3180,12 +3180,12 @@
             <a:pPr algn="ctr">
               <a:defRPr sz="1000" b="1">
                 <a:solidFill>
-                  <a:srgbClr val="0F766E"/>
-                </a:solidFill>
-              </a:defRPr>
-            </a:pPr>
-            <a:r>
-              <a:t>SMART INDIA HACKATHON (SIH) PRESENTATION</a:t>
+                  <a:srgbClr val="0E7490"/>
+                </a:solidFill>
+              </a:defRPr>
+            </a:pPr>
+            <a:r>
+              <a:t>SMART INDIA HACKATHON (SIH)</a:t>
             </a:r>
           </a:p>
         </p:txBody>
@@ -3198,8 +3198,8 @@
         </p:nvSpPr>
         <p:spPr>
           <a:xfrm>
-            <a:off x="1097280" y="1280160"/>
-            <a:ext cx="10058400" cy="1463040"/>
+            <a:off x="914400" y="1234440"/>
+            <a:ext cx="10332720" cy="1463040"/>
           </a:xfrm>
           <a:prstGeom prst="rect">
             <a:avLst/>
@@ -3220,23 +3220,19 @@
               </a:defRPr>
             </a:pPr>
             <a:r>
-              <a:t>Automated Employee Leave Management</a:t>
-            </a:r>
-            <a:br/>
-            <a:r>
-              <a:t>&amp; Quota Tracking System (ELMS)</a:t>
-            </a:r>
-          </a:p>
-          <a:p>
-            <a:pPr>
-              <a:defRPr sz="1400">
-                <a:solidFill>
-                  <a:srgbClr val="64748B"/>
-                </a:solidFill>
-              </a:defRPr>
-            </a:pPr>
-            <a:r>
-              <a:t>Eliminating manual approval friction, human ledger errors, and departmental leave overlaps through cloud automation.</a:t>
+              <a:t>Employee Leave Management System</a:t>
+            </a:r>
+          </a:p>
+          <a:p>
+            <a:pPr>
+              <a:defRPr sz="1600">
+                <a:solidFill>
+                  <a:srgbClr val="0E7490"/>
+                </a:solidFill>
+              </a:defRPr>
+            </a:pPr>
+            <a:r>
+              <a:t>Smart, Cloud-Based Leave Application &amp; Real-Time Quota Tracking</a:t>
             </a:r>
           </a:p>
         </p:txBody>
@@ -3249,8 +3245,8 @@
         </p:nvSpPr>
         <p:spPr>
           <a:xfrm>
-            <a:off x="1097280" y="3108960"/>
-            <a:ext cx="4846320" cy="3108960"/>
+            <a:off x="914400" y="2926080"/>
+            <a:ext cx="4937760" cy="3291840"/>
           </a:xfrm>
           <a:prstGeom prst="roundRect">
             <a:avLst/>
@@ -3285,12 +3281,12 @@
             <a:pPr algn="ctr">
               <a:defRPr sz="1200" b="1">
                 <a:solidFill>
-                  <a:srgbClr val="0F766E"/>
-                </a:solidFill>
-              </a:defRPr>
-            </a:pPr>
-            <a:r>
-              <a:t>PROJECT &amp; DOMAIN DETAILS</a:t>
+                  <a:srgbClr val="0E7490"/>
+                </a:solidFill>
+              </a:defRPr>
+            </a:pPr>
+            <a:r>
+              <a:t>PROJECT SUMMARY</a:t>
             </a:r>
           </a:p>
           <a:p>
@@ -3302,7 +3298,7 @@
               </a:defRPr>
             </a:pPr>
             <a:r>
-              <a:t>Theme / Category: Smart Automation / Office Modernization</a:t>
+              <a:t>Theme: Smart Automation / Office Operations</a:t>
             </a:r>
           </a:p>
           <a:p>
@@ -3314,7 +3310,7 @@
               </a:defRPr>
             </a:pPr>
             <a:r>
-              <a:t>Problem Statement Focus: Workforce Leave Governance &amp; Real-Time Tracking</a:t>
+              <a:t>Problem Focus: Eliminating paper leaves &amp; date conflicts</a:t>
             </a:r>
           </a:p>
           <a:p>
@@ -3326,7 +3322,7 @@
               </a:defRPr>
             </a:pPr>
             <a:r>
-              <a:t>Target Sectors: Educational Departments, SMEs &amp; Modern Startups</a:t>
+              <a:t>Target Users: Colleges, Departments &amp; Small Enterprises</a:t>
             </a:r>
           </a:p>
           <a:p>
@@ -3338,7 +3334,7 @@
               </a:defRPr>
             </a:pPr>
             <a:r>
-              <a:t>Deployment Status: Live &amp; Production-Ready on Cloud</a:t>
+              <a:t>Live Status: Deployed &amp; Live on Cloud</a:t>
             </a:r>
           </a:p>
         </p:txBody>
@@ -3351,8 +3347,8 @@
         </p:nvSpPr>
         <p:spPr>
           <a:xfrm>
-            <a:off x="6217920" y="3108960"/>
-            <a:ext cx="4937760" cy="3108960"/>
+            <a:off x="6217920" y="2926080"/>
+            <a:ext cx="5029200" cy="3291840"/>
           </a:xfrm>
           <a:prstGeom prst="roundRect">
             <a:avLst/>
@@ -3387,12 +3383,12 @@
             <a:pPr algn="ctr">
               <a:defRPr sz="1200" b="1">
                 <a:solidFill>
-                  <a:srgbClr val="0F766E"/>
-                </a:solidFill>
-              </a:defRPr>
-            </a:pPr>
-            <a:r>
-              <a:t>TEAM INFORMATION</a:t>
+                  <a:srgbClr val="0E7490"/>
+                </a:solidFill>
+              </a:defRPr>
+            </a:pPr>
+            <a:r>
+              <a:t>TEAM DETAILS</a:t>
             </a:r>
           </a:p>
           <a:p>
@@ -3416,7 +3412,7 @@
               </a:defRPr>
             </a:pPr>
             <a:r>
-              <a:t>• Team Leader: [Your Name] (Architecture &amp; Full Stack)</a:t>
+              <a:t>• Team Leader: [Name] (Full Stack Architecture)</a:t>
             </a:r>
           </a:p>
           <a:p>
@@ -3428,7 +3424,7 @@
               </a:defRPr>
             </a:pPr>
             <a:r>
-              <a:t>• Member 2: [Name] (Backend API &amp; Cloud Infrastructure)</a:t>
+              <a:t>• Member 2: [Name] (Backend API &amp; Cloud)</a:t>
             </a:r>
           </a:p>
           <a:p>
@@ -3440,7 +3436,7 @@
               </a:defRPr>
             </a:pPr>
             <a:r>
-              <a:t>• Member 3: [Name] (Database &amp; Data Integrity)</a:t>
+              <a:t>• Member 3: [Name] (Database &amp; Security)</a:t>
             </a:r>
           </a:p>
           <a:p>
@@ -3452,7 +3448,7 @@
               </a:defRPr>
             </a:pPr>
             <a:r>
-              <a:t>• Member 4: [Name] (UI/UX &amp; Accessibility)</a:t>
+              <a:t>• Member 4: [Name] (UI/UX Design)</a:t>
             </a:r>
           </a:p>
           <a:p>
@@ -3464,7 +3460,7 @@
               </a:defRPr>
             </a:pPr>
             <a:r>
-              <a:t>• Member 5: [Name] (QA &amp; Conflict Validation Engine)</a:t>
+              <a:t>• Member 5: [Name] (Testing &amp; Validation Engine)</a:t>
             </a:r>
           </a:p>
           <a:p>
@@ -3476,7 +3472,7 @@
               </a:defRPr>
             </a:pPr>
             <a:r>
-              <a:t>• Member 6: [Name] (Documentation &amp; Business Modeling)</a:t>
+              <a:t>• Member 6: [Name] (Business Analysis &amp; Docs)</a:t>
             </a:r>
           </a:p>
         </p:txBody>
@@ -3508,7 +3504,7 @@
         <p:spPr>
           <a:xfrm>
             <a:off x="731520" y="365760"/>
-            <a:ext cx="10698480" cy="365760"/>
+            <a:ext cx="10698480" cy="320040"/>
           </a:xfrm>
           <a:prstGeom prst="rect">
             <a:avLst/>
@@ -3522,14 +3518,14 @@
           <a:lstStyle/>
           <a:p>
             <a:pPr>
-              <a:defRPr sz="1100" b="1">
-                <a:solidFill>
-                  <a:srgbClr val="0F766E"/>
-                </a:solidFill>
-              </a:defRPr>
-            </a:pPr>
-            <a:r>
-              <a:t>SMART INDIA HACKATHON 2024 / 2025</a:t>
+              <a:defRPr sz="1000" b="1">
+                <a:solidFill>
+                  <a:srgbClr val="0E7490"/>
+                </a:solidFill>
+              </a:defRPr>
+            </a:pPr>
+            <a:r>
+              <a:t>SIH PRESENTATION  |  SLIDE 2 OF 6</a:t>
             </a:r>
           </a:p>
         </p:txBody>
@@ -3543,7 +3539,7 @@
         <p:spPr>
           <a:xfrm>
             <a:off x="731520" y="640080"/>
-            <a:ext cx="10698480" cy="731520"/>
+            <a:ext cx="10698480" cy="548640"/>
           </a:xfrm>
           <a:prstGeom prst="rect">
             <a:avLst/>
@@ -3557,38 +3553,73 @@
           <a:lstStyle/>
           <a:p>
             <a:pPr>
-              <a:defRPr sz="2400" b="1">
+              <a:defRPr sz="2200" b="1">
                 <a:solidFill>
                   <a:srgbClr val="0F172A"/>
                 </a:solidFill>
               </a:defRPr>
             </a:pPr>
             <a:r>
-              <a:t>Slide 2: Problem Statement &amp; Proposed Solution</a:t>
-            </a:r>
-          </a:p>
-        </p:txBody>
-      </p:sp>
-      <p:sp>
-        <p:nvSpPr>
-          <p:cNvPr id="4" name="Rounded Rectangle 3"/>
+              <a:t>Problem Statement &amp; Proposed Solution</a:t>
+            </a:r>
+          </a:p>
+        </p:txBody>
+      </p:sp>
+      <p:sp>
+        <p:nvSpPr>
+          <p:cNvPr id="4" name="TextBox 3"/>
+          <p:cNvSpPr txBox="1"/>
+          <p:nvPr/>
+        </p:nvSpPr>
+        <p:spPr>
+          <a:xfrm>
+            <a:off x="731520" y="1188720"/>
+            <a:ext cx="10698480" cy="320040"/>
+          </a:xfrm>
+          <a:prstGeom prst="rect">
+            <a:avLst/>
+          </a:prstGeom>
+          <a:noFill/>
+        </p:spPr>
+        <p:txBody>
+          <a:bodyPr wrap="square">
+            <a:spAutoFit/>
+          </a:bodyPr>
+          <a:lstStyle/>
+          <a:p>
+            <a:pPr>
+              <a:defRPr sz="1100">
+                <a:solidFill>
+                  <a:srgbClr val="64748B"/>
+                </a:solidFill>
+              </a:defRPr>
+            </a:pPr>
+            <a:r>
+              <a:t>Addressing manual inefficiencies with automated digital governance</a:t>
+            </a:r>
+          </a:p>
+        </p:txBody>
+      </p:sp>
+      <p:sp>
+        <p:nvSpPr>
+          <p:cNvPr id="5" name="Rounded Rectangle 4"/>
           <p:cNvSpPr/>
           <p:nvPr/>
         </p:nvSpPr>
         <p:spPr>
           <a:xfrm>
-            <a:off x="731520" y="1554480"/>
-            <a:ext cx="5212080" cy="4846320"/>
+            <a:off x="731520" y="1645920"/>
+            <a:ext cx="5120640" cy="4663440"/>
           </a:xfrm>
           <a:prstGeom prst="roundRect">
             <a:avLst/>
           </a:prstGeom>
           <a:solidFill>
-            <a:srgbClr val="FEF2F2"/>
+            <a:srgbClr val="FFF1F2"/>
           </a:solidFill>
           <a:ln>
             <a:solidFill>
-              <a:srgbClr val="FECACA"/>
+              <a:srgbClr val="FECDD3"/>
             </a:solidFill>
           </a:ln>
         </p:spPr>
@@ -3611,26 +3642,26 @@
           <a:lstStyle/>
           <a:p>
             <a:pPr algn="ctr">
-              <a:defRPr sz="1300" b="1">
-                <a:solidFill>
-                  <a:srgbClr val="B91C1C"/>
-                </a:solidFill>
-              </a:defRPr>
-            </a:pPr>
-            <a:r>
-              <a:t>THE PROBLEM (CURRENT STATE &amp; PAIN POINTS)</a:t>
-            </a:r>
-          </a:p>
-          <a:p>
-            <a:pPr>
-              <a:defRPr sz="1100" b="1">
-                <a:solidFill>
-                  <a:srgbClr val="991B1B"/>
-                </a:solidFill>
-              </a:defRPr>
-            </a:pPr>
-            <a:r>
-              <a:t>✖ Fragmented &amp; Manual Channels</a:t>
+              <a:defRPr sz="1400" b="1">
+                <a:solidFill>
+                  <a:srgbClr val="E11D48"/>
+                </a:solidFill>
+              </a:defRPr>
+            </a:pPr>
+            <a:r>
+              <a:t>CURRENT CHALLENGES</a:t>
+            </a:r>
+          </a:p>
+          <a:p>
+            <a:pPr>
+              <a:defRPr sz="1200" b="1">
+                <a:solidFill>
+                  <a:srgbClr val="E11D48"/>
+                </a:solidFill>
+              </a:defRPr>
+            </a:pPr>
+            <a:r>
+              <a:t>✖  Lost &amp; Untracked Requests</a:t>
             </a:r>
           </a:p>
           <a:p>
@@ -3642,19 +3673,19 @@
               </a:defRPr>
             </a:pPr>
             <a:r>
-              <a:t>Leaves are requested via paper forms, informal chat apps, and scattered emails, leading to lost requests and untracked records.</a:t>
-            </a:r>
-          </a:p>
-          <a:p>
-            <a:pPr>
-              <a:defRPr sz="1100" b="1">
-                <a:solidFill>
-                  <a:srgbClr val="991B1B"/>
-                </a:solidFill>
-              </a:defRPr>
-            </a:pPr>
-            <a:r>
-              <a:t>✖ Quota Ambiguity &amp; Balance Disputes</a:t>
+              <a:t>    Paper slips, emails, and chats get misplaced, causing confusion.</a:t>
+            </a:r>
+          </a:p>
+          <a:p>
+            <a:pPr>
+              <a:defRPr sz="1200" b="1">
+                <a:solidFill>
+                  <a:srgbClr val="E11D48"/>
+                </a:solidFill>
+              </a:defRPr>
+            </a:pPr>
+            <a:r>
+              <a:t>✖  No Balance Transparency</a:t>
             </a:r>
           </a:p>
           <a:p>
@@ -3666,19 +3697,19 @@
               </a:defRPr>
             </a:pPr>
             <a:r>
-              <a:t>Employees lack real-time visibility into remaining leave quotas, generating repetitive HR inquiries and calculation disputes.</a:t>
-            </a:r>
-          </a:p>
-          <a:p>
-            <a:pPr>
-              <a:defRPr sz="1100" b="1">
-                <a:solidFill>
-                  <a:srgbClr val="991B1B"/>
-                </a:solidFill>
-              </a:defRPr>
-            </a:pPr>
-            <a:r>
-              <a:t>✖ Departmental Operational Blindspots</a:t>
+              <a:t>    Employees don't know remaining leave quotas without asking HR.</a:t>
+            </a:r>
+          </a:p>
+          <a:p>
+            <a:pPr>
+              <a:defRPr sz="1200" b="1">
+                <a:solidFill>
+                  <a:srgbClr val="E11D48"/>
+                </a:solidFill>
+              </a:defRPr>
+            </a:pPr>
+            <a:r>
+              <a:t>✖  Departmental Staff Shortages</a:t>
             </a:r>
           </a:p>
           <a:p>
@@ -3690,19 +3721,19 @@
               </a:defRPr>
             </a:pPr>
             <a:r>
-              <a:t>Absence of centralized leave visibility results in simultaneous approvals of key personnel, causing critical staffing shortages.</a:t>
-            </a:r>
-          </a:p>
-          <a:p>
-            <a:pPr>
-              <a:defRPr sz="1100" b="1">
-                <a:solidFill>
-                  <a:srgbClr val="991B1B"/>
-                </a:solidFill>
-              </a:defRPr>
-            </a:pPr>
-            <a:r>
-              <a:t>✖ Excessive Administrative Burden</a:t>
+              <a:t>    Simultaneous leaves for key staff happen due to zero central visibility.</a:t>
+            </a:r>
+          </a:p>
+          <a:p>
+            <a:pPr>
+              <a:defRPr sz="1200" b="1">
+                <a:solidFill>
+                  <a:srgbClr val="E11D48"/>
+                </a:solidFill>
+              </a:defRPr>
+            </a:pPr>
+            <a:r>
+              <a:t>✖  Slow, Manual Approvals</a:t>
             </a:r>
           </a:p>
           <a:p>
@@ -3714,21 +3745,21 @@
               </a:defRPr>
             </a:pPr>
             <a:r>
-              <a:t>Managers spend hours manually calculating days, validating eligibility, and reconciling paper ledgers.</a:t>
-            </a:r>
-          </a:p>
-        </p:txBody>
-      </p:sp>
-      <p:sp>
-        <p:nvSpPr>
-          <p:cNvPr id="5" name="Rounded Rectangle 4"/>
+              <a:t>    Multi-day delays waiting for physical sign-offs and paper ledger math.</a:t>
+            </a:r>
+          </a:p>
+        </p:txBody>
+      </p:sp>
+      <p:sp>
+        <p:nvSpPr>
+          <p:cNvPr id="6" name="Rounded Rectangle 5"/>
           <p:cNvSpPr/>
           <p:nvPr/>
         </p:nvSpPr>
         <p:spPr>
           <a:xfrm>
-            <a:off x="6217920" y="1554480"/>
-            <a:ext cx="5212080" cy="4846320"/>
+            <a:off x="6217920" y="1645920"/>
+            <a:ext cx="5212080" cy="4663440"/>
           </a:xfrm>
           <a:prstGeom prst="roundRect">
             <a:avLst/>
@@ -3761,26 +3792,26 @@
           <a:lstStyle/>
           <a:p>
             <a:pPr algn="ctr">
-              <a:defRPr sz="1300" b="1">
-                <a:solidFill>
-                  <a:srgbClr val="0F766E"/>
-                </a:solidFill>
-              </a:defRPr>
-            </a:pPr>
-            <a:r>
-              <a:t>PROPOSED SOLUTION (AUTOMATED CLOUD PLATFORM)</a:t>
-            </a:r>
-          </a:p>
-          <a:p>
-            <a:pPr>
-              <a:defRPr sz="1100" b="1">
-                <a:solidFill>
-                  <a:srgbClr val="0F766E"/>
-                </a:solidFill>
-              </a:defRPr>
-            </a:pPr>
-            <a:r>
-              <a:t>✔ Unified Self-Service Portal</a:t>
+              <a:defRPr sz="1400" b="1">
+                <a:solidFill>
+                  <a:srgbClr val="0E7490"/>
+                </a:solidFill>
+              </a:defRPr>
+            </a:pPr>
+            <a:r>
+              <a:t>OUR PROPOSED SOLUTION</a:t>
+            </a:r>
+          </a:p>
+          <a:p>
+            <a:pPr>
+              <a:defRPr sz="1200" b="1">
+                <a:solidFill>
+                  <a:srgbClr val="0E7490"/>
+                </a:solidFill>
+              </a:defRPr>
+            </a:pPr>
+            <a:r>
+              <a:t>✔  100% Digital Self-Service</a:t>
             </a:r>
           </a:p>
           <a:p>
@@ -3792,19 +3823,19 @@
               </a:defRPr>
             </a:pPr>
             <a:r>
-              <a:t>Empowers employees to check real-time quotas across leave types and submit transparent digital requests in seconds.</a:t>
-            </a:r>
-          </a:p>
-          <a:p>
-            <a:pPr>
-              <a:defRPr sz="1100" b="1">
-                <a:solidFill>
-                  <a:srgbClr val="0F766E"/>
-                </a:solidFill>
-              </a:defRPr>
-            </a:pPr>
-            <a:r>
-              <a:t>✔ Proactive Validation Engine</a:t>
+              <a:t>    Employees apply online in seconds and see live approval status.</a:t>
+            </a:r>
+          </a:p>
+          <a:p>
+            <a:pPr>
+              <a:defRPr sz="1200" b="1">
+                <a:solidFill>
+                  <a:srgbClr val="0E7490"/>
+                </a:solidFill>
+              </a:defRPr>
+            </a:pPr>
+            <a:r>
+              <a:t>✔  Live Quota &amp; Balance Tracking</a:t>
             </a:r>
           </a:p>
           <a:p>
@@ -3816,19 +3847,19 @@
               </a:defRPr>
             </a:pPr>
             <a:r>
-              <a:t>Automated rules prevent overlapping date requests and enforce quota limits before submission, ensuring zero invalid entries.</a:t>
-            </a:r>
-          </a:p>
-          <a:p>
-            <a:pPr>
-              <a:defRPr sz="1100" b="1">
-                <a:solidFill>
-                  <a:srgbClr val="0F766E"/>
-                </a:solidFill>
-              </a:defRPr>
-            </a:pPr>
-            <a:r>
-              <a:t>✔ Admin Central Command Center</a:t>
+              <a:t>    Real-time cards show used vs available days for every leave type.</a:t>
+            </a:r>
+          </a:p>
+          <a:p>
+            <a:pPr>
+              <a:defRPr sz="1200" b="1">
+                <a:solidFill>
+                  <a:srgbClr val="0E7490"/>
+                </a:solidFill>
+              </a:defRPr>
+            </a:pPr>
+            <a:r>
+              <a:t>✔  Smart Overlap Prevention</a:t>
             </a:r>
           </a:p>
           <a:p>
@@ -3840,19 +3871,19 @@
               </a:defRPr>
             </a:pPr>
             <a:r>
-              <a:t>Live dashboard showing pending approvals, employees on leave today, and department-wise metrics for informed decision-making.</a:t>
-            </a:r>
-          </a:p>
-          <a:p>
-            <a:pPr>
-              <a:defRPr sz="1100" b="1">
-                <a:solidFill>
-                  <a:srgbClr val="0F766E"/>
-                </a:solidFill>
-              </a:defRPr>
-            </a:pPr>
-            <a:r>
-              <a:t>✔ Automated Balance Reconciliation</a:t>
+              <a:t>    Built-in validation stops overlapping requests before submission.</a:t>
+            </a:r>
+          </a:p>
+          <a:p>
+            <a:pPr>
+              <a:defRPr sz="1200" b="1">
+                <a:solidFill>
+                  <a:srgbClr val="0E7490"/>
+                </a:solidFill>
+              </a:defRPr>
+            </a:pPr>
+            <a:r>
+              <a:t>✔  1-Click Admin Approvals</a:t>
             </a:r>
           </a:p>
           <a:p>
@@ -3864,7 +3895,7 @@
               </a:defRPr>
             </a:pPr>
             <a:r>
-              <a:t>One-click approval/rejection with remarks automatically deducts days from personal quota with an auditable historical log.</a:t>
+              <a:t>    Managers review with remarks; leave balances auto-deduct instantly.</a:t>
             </a:r>
           </a:p>
         </p:txBody>
@@ -3896,7 +3927,7 @@
         <p:spPr>
           <a:xfrm>
             <a:off x="731520" y="365760"/>
-            <a:ext cx="10698480" cy="365760"/>
+            <a:ext cx="10698480" cy="320040"/>
           </a:xfrm>
           <a:prstGeom prst="rect">
             <a:avLst/>
@@ -3910,14 +3941,14 @@
           <a:lstStyle/>
           <a:p>
             <a:pPr>
-              <a:defRPr sz="1100" b="1">
-                <a:solidFill>
-                  <a:srgbClr val="0F766E"/>
-                </a:solidFill>
-              </a:defRPr>
-            </a:pPr>
-            <a:r>
-              <a:t>SMART INDIA HACKATHON 2024 / 2025</a:t>
+              <a:defRPr sz="1000" b="1">
+                <a:solidFill>
+                  <a:srgbClr val="0E7490"/>
+                </a:solidFill>
+              </a:defRPr>
+            </a:pPr>
+            <a:r>
+              <a:t>SIH PRESENTATION  |  SLIDE 3 OF 6</a:t>
             </a:r>
           </a:p>
         </p:txBody>
@@ -3931,7 +3962,7 @@
         <p:spPr>
           <a:xfrm>
             <a:off x="731520" y="640080"/>
-            <a:ext cx="10698480" cy="731520"/>
+            <a:ext cx="10698480" cy="548640"/>
           </a:xfrm>
           <a:prstGeom prst="rect">
             <a:avLst/>
@@ -3945,28 +3976,63 @@
           <a:lstStyle/>
           <a:p>
             <a:pPr>
-              <a:defRPr sz="2400" b="1">
+              <a:defRPr sz="2200" b="1">
                 <a:solidFill>
                   <a:srgbClr val="0F172A"/>
                 </a:solidFill>
               </a:defRPr>
             </a:pPr>
             <a:r>
-              <a:t>Slide 3: Technical Approach, Architecture &amp; Innovation</a:t>
-            </a:r>
-          </a:p>
-        </p:txBody>
-      </p:sp>
-      <p:sp>
-        <p:nvSpPr>
-          <p:cNvPr id="4" name="Rounded Rectangle 3"/>
+              <a:t>Technical Approach &amp; Core Workflow</a:t>
+            </a:r>
+          </a:p>
+        </p:txBody>
+      </p:sp>
+      <p:sp>
+        <p:nvSpPr>
+          <p:cNvPr id="4" name="TextBox 3"/>
+          <p:cNvSpPr txBox="1"/>
+          <p:nvPr/>
+        </p:nvSpPr>
+        <p:spPr>
+          <a:xfrm>
+            <a:off x="731520" y="1188720"/>
+            <a:ext cx="10698480" cy="320040"/>
+          </a:xfrm>
+          <a:prstGeom prst="rect">
+            <a:avLst/>
+          </a:prstGeom>
+          <a:noFill/>
+        </p:spPr>
+        <p:txBody>
+          <a:bodyPr wrap="square">
+            <a:spAutoFit/>
+          </a:bodyPr>
+          <a:lstStyle/>
+          <a:p>
+            <a:pPr>
+              <a:defRPr sz="1100">
+                <a:solidFill>
+                  <a:srgbClr val="64748B"/>
+                </a:solidFill>
+              </a:defRPr>
+            </a:pPr>
+            <a:r>
+              <a:t>End-to-end automated architecture designed for zero friction</a:t>
+            </a:r>
+          </a:p>
+        </p:txBody>
+      </p:sp>
+      <p:sp>
+        <p:nvSpPr>
+          <p:cNvPr id="5" name="Rounded Rectangle 4"/>
           <p:cNvSpPr/>
           <p:nvPr/>
         </p:nvSpPr>
         <p:spPr>
           <a:xfrm>
-            <a:off x="731520" y="1554480"/>
-            <a:ext cx="3383280" cy="2743200"/>
+            <a:off x="731520" y="1645920"/>
+            <a:ext cx="3291840" cy="2926080"/>
           </a:xfrm>
           <a:prstGeom prst="roundRect">
             <a:avLst/>
@@ -3999,88 +4065,88 @@
           <a:lstStyle/>
           <a:p>
             <a:pPr algn="ctr">
+              <a:defRPr sz="1200" b="1">
+                <a:solidFill>
+                  <a:srgbClr val="0E7490"/>
+                </a:solidFill>
+              </a:defRPr>
+            </a:pPr>
+            <a:r>
+              <a:t>STEP 1: EMPLOYEE</a:t>
+            </a:r>
+          </a:p>
+          <a:p>
+            <a:pPr>
               <a:defRPr sz="1100" b="1">
                 <a:solidFill>
-                  <a:srgbClr val="0F766E"/>
-                </a:solidFill>
-              </a:defRPr>
-            </a:pPr>
-            <a:r>
-              <a:t>TIER 1: PRESENTATION LAYER</a:t>
-            </a:r>
-          </a:p>
-          <a:p>
-            <a:pPr>
-              <a:defRPr sz="1000" b="1">
-                <a:solidFill>
                   <a:srgbClr val="0F172A"/>
                 </a:solidFill>
               </a:defRPr>
             </a:pPr>
             <a:r>
-              <a:t>Role-Based Web Client</a:t>
-            </a:r>
-          </a:p>
-          <a:p>
-            <a:pPr>
-              <a:defRPr sz="950">
+              <a:t>Apply &amp; Track</a:t>
+            </a:r>
+          </a:p>
+          <a:p>
+            <a:pPr>
+              <a:defRPr sz="1000">
                 <a:solidFill>
                   <a:srgbClr val="1E293B"/>
                 </a:solidFill>
               </a:defRPr>
             </a:pPr>
             <a:r>
-              <a:t>• Dedicated portals for Employees and Administrators</a:t>
-            </a:r>
-          </a:p>
-          <a:p>
-            <a:pPr>
-              <a:defRPr sz="950">
+              <a:t>• Log in to secure self-service portal</a:t>
+            </a:r>
+          </a:p>
+          <a:p>
+            <a:pPr>
+              <a:defRPr sz="1000">
                 <a:solidFill>
                   <a:srgbClr val="1E293B"/>
                 </a:solidFill>
               </a:defRPr>
             </a:pPr>
             <a:r>
-              <a:t>• Real-time responsive layout across mobile and desktop</a:t>
-            </a:r>
-          </a:p>
-          <a:p>
-            <a:pPr>
-              <a:defRPr sz="950">
+              <a:t>• View real-time quota balances</a:t>
+            </a:r>
+          </a:p>
+          <a:p>
+            <a:pPr>
+              <a:defRPr sz="1000">
                 <a:solidFill>
                   <a:srgbClr val="1E293B"/>
                 </a:solidFill>
               </a:defRPr>
             </a:pPr>
             <a:r>
-              <a:t>• Interactive statistics cards &amp; dynamic balance indicators</a:t>
-            </a:r>
-          </a:p>
-          <a:p>
-            <a:pPr>
-              <a:defRPr sz="950">
+              <a:t>• Select dates &amp; enter reason</a:t>
+            </a:r>
+          </a:p>
+          <a:p>
+            <a:pPr>
+              <a:defRPr sz="1000">
                 <a:solidFill>
                   <a:srgbClr val="1E293B"/>
                 </a:solidFill>
               </a:defRPr>
             </a:pPr>
             <a:r>
-              <a:t>• Zero client install — runs in any standard browser</a:t>
-            </a:r>
-          </a:p>
-        </p:txBody>
-      </p:sp>
-      <p:sp>
-        <p:nvSpPr>
-          <p:cNvPr id="5" name="Rounded Rectangle 4"/>
+              <a:t>• Automatic day duration calculation</a:t>
+            </a:r>
+          </a:p>
+        </p:txBody>
+      </p:sp>
+      <p:sp>
+        <p:nvSpPr>
+          <p:cNvPr id="6" name="Rounded Rectangle 5"/>
           <p:cNvSpPr/>
           <p:nvPr/>
         </p:nvSpPr>
         <p:spPr>
           <a:xfrm>
-            <a:off x="4389120" y="1554480"/>
-            <a:ext cx="3383280" cy="2743200"/>
+            <a:off x="4389120" y="1645920"/>
+            <a:ext cx="3291840" cy="2926080"/>
           </a:xfrm>
           <a:prstGeom prst="roundRect">
             <a:avLst/>
@@ -4113,88 +4179,88 @@
           <a:lstStyle/>
           <a:p>
             <a:pPr algn="ctr">
+              <a:defRPr sz="1200" b="1">
+                <a:solidFill>
+                  <a:srgbClr val="0E7490"/>
+                </a:solidFill>
+              </a:defRPr>
+            </a:pPr>
+            <a:r>
+              <a:t>STEP 2: VALIDATION</a:t>
+            </a:r>
+          </a:p>
+          <a:p>
+            <a:pPr>
               <a:defRPr sz="1100" b="1">
                 <a:solidFill>
-                  <a:srgbClr val="0F766E"/>
-                </a:solidFill>
-              </a:defRPr>
-            </a:pPr>
-            <a:r>
-              <a:t>TIER 2: APPLICATION &amp; LOGIC</a:t>
-            </a:r>
-          </a:p>
-          <a:p>
-            <a:pPr>
-              <a:defRPr sz="1000" b="1">
-                <a:solidFill>
                   <a:srgbClr val="0F172A"/>
                 </a:solidFill>
               </a:defRPr>
             </a:pPr>
             <a:r>
-              <a:t>Cloud API Gateway &amp; Logic Engine</a:t>
-            </a:r>
-          </a:p>
-          <a:p>
-            <a:pPr>
-              <a:defRPr sz="950">
+              <a:t>Smart Rule Engine</a:t>
+            </a:r>
+          </a:p>
+          <a:p>
+            <a:pPr>
+              <a:defRPr sz="1000">
                 <a:solidFill>
                   <a:srgbClr val="1E293B"/>
                 </a:solidFill>
               </a:defRPr>
             </a:pPr>
             <a:r>
-              <a:t>• Token-based cryptographic session verification</a:t>
-            </a:r>
-          </a:p>
-          <a:p>
-            <a:pPr>
-              <a:defRPr sz="950">
+              <a:t>• Checks sufficient quota balance</a:t>
+            </a:r>
+          </a:p>
+          <a:p>
+            <a:pPr>
+              <a:defRPr sz="1000">
                 <a:solidFill>
                   <a:srgbClr val="1E293B"/>
                 </a:solidFill>
               </a:defRPr>
             </a:pPr>
             <a:r>
-              <a:t>• Proactive date-overlap prevention algorithm</a:t>
-            </a:r>
-          </a:p>
-          <a:p>
-            <a:pPr>
-              <a:defRPr sz="950">
+              <a:t>• Detects &amp; blocks date overlaps</a:t>
+            </a:r>
+          </a:p>
+          <a:p>
+            <a:pPr>
+              <a:defRPr sz="1000">
                 <a:solidFill>
                   <a:srgbClr val="1E293B"/>
                 </a:solidFill>
               </a:defRPr>
             </a:pPr>
             <a:r>
-              <a:t>• Automated day duration calculator (inclusive dates)</a:t>
-            </a:r>
-          </a:p>
-          <a:p>
-            <a:pPr>
-              <a:defRPr sz="950">
+              <a:t>• Authenticates user role securely</a:t>
+            </a:r>
+          </a:p>
+          <a:p>
+            <a:pPr>
+              <a:defRPr sz="1000">
                 <a:solidFill>
                   <a:srgbClr val="1E293B"/>
                 </a:solidFill>
               </a:defRPr>
             </a:pPr>
             <a:r>
-              <a:t>• Status transition workflows with audit remarks</a:t>
-            </a:r>
-          </a:p>
-        </p:txBody>
-      </p:sp>
-      <p:sp>
-        <p:nvSpPr>
-          <p:cNvPr id="6" name="Rounded Rectangle 5"/>
+              <a:t>• Queues valid request for review</a:t>
+            </a:r>
+          </a:p>
+        </p:txBody>
+      </p:sp>
+      <p:sp>
+        <p:nvSpPr>
+          <p:cNvPr id="7" name="Rounded Rectangle 6"/>
           <p:cNvSpPr/>
           <p:nvPr/>
         </p:nvSpPr>
         <p:spPr>
           <a:xfrm>
-            <a:off x="8046720" y="1554480"/>
-            <a:ext cx="3383280" cy="2743200"/>
+            <a:off x="8046720" y="1645920"/>
+            <a:ext cx="3291840" cy="2926080"/>
           </a:xfrm>
           <a:prstGeom prst="roundRect">
             <a:avLst/>
@@ -4227,88 +4293,88 @@
           <a:lstStyle/>
           <a:p>
             <a:pPr algn="ctr">
+              <a:defRPr sz="1200" b="1">
+                <a:solidFill>
+                  <a:srgbClr val="0E7490"/>
+                </a:solidFill>
+              </a:defRPr>
+            </a:pPr>
+            <a:r>
+              <a:t>STEP 3: ADMIN</a:t>
+            </a:r>
+          </a:p>
+          <a:p>
+            <a:pPr>
               <a:defRPr sz="1100" b="1">
                 <a:solidFill>
-                  <a:srgbClr val="0F766E"/>
-                </a:solidFill>
-              </a:defRPr>
-            </a:pPr>
-            <a:r>
-              <a:t>TIER 3: DATA &amp; PERSISTENCE</a:t>
-            </a:r>
-          </a:p>
-          <a:p>
-            <a:pPr>
-              <a:defRPr sz="1000" b="1">
-                <a:solidFill>
                   <a:srgbClr val="0F172A"/>
                 </a:solidFill>
               </a:defRPr>
             </a:pPr>
             <a:r>
-              <a:t>Cloud Distributed Document Store</a:t>
-            </a:r>
-          </a:p>
-          <a:p>
-            <a:pPr>
-              <a:defRPr sz="950">
+              <a:t>Review &amp; Settle</a:t>
+            </a:r>
+          </a:p>
+          <a:p>
+            <a:pPr>
+              <a:defRPr sz="1000">
                 <a:solidFill>
                   <a:srgbClr val="1E293B"/>
                 </a:solidFill>
               </a:defRPr>
             </a:pPr>
             <a:r>
-              <a:t>• Normalized employee profiles &amp; credential hashes</a:t>
-            </a:r>
-          </a:p>
-          <a:p>
-            <a:pPr>
-              <a:defRPr sz="950">
+              <a:t>• Live metrics &amp; on-leave headcounts</a:t>
+            </a:r>
+          </a:p>
+          <a:p>
+            <a:pPr>
+              <a:defRPr sz="1000">
                 <a:solidFill>
                   <a:srgbClr val="1E293B"/>
                 </a:solidFill>
               </a:defRPr>
             </a:pPr>
             <a:r>
-              <a:t>• Dynamic leave type schemas with quota parameters</a:t>
-            </a:r>
-          </a:p>
-          <a:p>
-            <a:pPr>
-              <a:defRPr sz="950">
+              <a:t>• 1-click Approve or Reject with remarks</a:t>
+            </a:r>
+          </a:p>
+          <a:p>
+            <a:pPr>
+              <a:defRPr sz="1000">
                 <a:solidFill>
                   <a:srgbClr val="1E293B"/>
                 </a:solidFill>
               </a:defRPr>
             </a:pPr>
             <a:r>
-              <a:t>• Chronological leave request histories &amp; timestamps</a:t>
-            </a:r>
-          </a:p>
-          <a:p>
-            <a:pPr>
-              <a:defRPr sz="950">
+              <a:t>• Automatic balance deduction</a:t>
+            </a:r>
+          </a:p>
+          <a:p>
+            <a:pPr>
+              <a:defRPr sz="1000">
                 <a:solidFill>
                   <a:srgbClr val="1E293B"/>
                 </a:solidFill>
               </a:defRPr>
             </a:pPr>
             <a:r>
-              <a:t>• Automatic failover, backup &amp; high-availability clustering</a:t>
-            </a:r>
-          </a:p>
-        </p:txBody>
-      </p:sp>
-      <p:sp>
-        <p:nvSpPr>
-          <p:cNvPr id="7" name="Rounded Rectangle 6"/>
+              <a:t>• Permanent audit history maintained</a:t>
+            </a:r>
+          </a:p>
+        </p:txBody>
+      </p:sp>
+      <p:sp>
+        <p:nvSpPr>
+          <p:cNvPr id="8" name="Rounded Rectangle 7"/>
           <p:cNvSpPr/>
           <p:nvPr/>
         </p:nvSpPr>
         <p:spPr>
           <a:xfrm>
-            <a:off x="731520" y="4480560"/>
-            <a:ext cx="10698480" cy="1920240"/>
+            <a:off x="731520" y="4754880"/>
+            <a:ext cx="10698480" cy="1554480"/>
           </a:xfrm>
           <a:prstGeom prst="roundRect">
             <a:avLst/>
@@ -4341,14 +4407,14 @@
           <a:lstStyle/>
           <a:p>
             <a:pPr algn="ctr">
-              <a:defRPr sz="1200" b="1">
-                <a:solidFill>
-                  <a:srgbClr val="0F766E"/>
-                </a:solidFill>
-              </a:defRPr>
-            </a:pPr>
-            <a:r>
-              <a:t>KEY INNOVATIONS &amp; DISTINCT COMPETITIVE ADVANTAGES</a:t>
+              <a:defRPr sz="1100" b="1">
+                <a:solidFill>
+                  <a:srgbClr val="0E7490"/>
+                </a:solidFill>
+              </a:defRPr>
+            </a:pPr>
+            <a:r>
+              <a:t>CORE ARCHITECTURAL STRENGTHS</a:t>
             </a:r>
           </a:p>
           <a:p>
@@ -4360,7 +4426,7 @@
               </a:defRPr>
             </a:pPr>
             <a:r>
-              <a:t>★ Algorithmic Conflict Elimination: Intelligently scans active requests to reject overlapping leave applications before they reach managers.</a:t>
+              <a:t>★  Zero Client Installation: Runs seamlessly in any browser on desktop, laptop, or mobile.</a:t>
             </a:r>
           </a:p>
           <a:p>
@@ -4372,7 +4438,7 @@
               </a:defRPr>
             </a:pPr>
             <a:r>
-              <a:t>★ Referential Integrity Safeguard: Strictly guards historical records by barring deletion of leave categories linked to past or active employee applications.</a:t>
+              <a:t>★  Strict Role Isolation: Cryptographic session tokens guarantee private, secure employee and admin data.</a:t>
             </a:r>
           </a:p>
           <a:p>
@@ -4384,7 +4450,7 @@
               </a:defRPr>
             </a:pPr>
             <a:r>
-              <a:t>★ Real-Time Department Metrics: Provides live count of staff on leave today, empowering admins to maintain operational continuity.</a:t>
+              <a:t>★  Data Protection Safeguard: Prevents accidental deletion of leave categories that have linked records.</a:t>
             </a:r>
           </a:p>
         </p:txBody>
@@ -4416,7 +4482,7 @@
         <p:spPr>
           <a:xfrm>
             <a:off x="731520" y="365760"/>
-            <a:ext cx="10698480" cy="365760"/>
+            <a:ext cx="10698480" cy="320040"/>
           </a:xfrm>
           <a:prstGeom prst="rect">
             <a:avLst/>
@@ -4430,14 +4496,14 @@
           <a:lstStyle/>
           <a:p>
             <a:pPr>
-              <a:defRPr sz="1100" b="1">
-                <a:solidFill>
-                  <a:srgbClr val="0F766E"/>
-                </a:solidFill>
-              </a:defRPr>
-            </a:pPr>
-            <a:r>
-              <a:t>SMART INDIA HACKATHON 2024 / 2025</a:t>
+              <a:defRPr sz="1000" b="1">
+                <a:solidFill>
+                  <a:srgbClr val="0E7490"/>
+                </a:solidFill>
+              </a:defRPr>
+            </a:pPr>
+            <a:r>
+              <a:t>SIH PRESENTATION  |  SLIDE 4 OF 6</a:t>
             </a:r>
           </a:p>
         </p:txBody>
@@ -4451,7 +4517,7 @@
         <p:spPr>
           <a:xfrm>
             <a:off x="731520" y="640080"/>
-            <a:ext cx="10698480" cy="731520"/>
+            <a:ext cx="10698480" cy="548640"/>
           </a:xfrm>
           <a:prstGeom prst="rect">
             <a:avLst/>
@@ -4465,28 +4531,63 @@
           <a:lstStyle/>
           <a:p>
             <a:pPr>
-              <a:defRPr sz="2400" b="1">
+              <a:defRPr sz="2200" b="1">
                 <a:solidFill>
                   <a:srgbClr val="0F172A"/>
                 </a:solidFill>
               </a:defRPr>
             </a:pPr>
             <a:r>
-              <a:t>Slide 4: Feasibility, Viability &amp; Risk Analysis</a:t>
-            </a:r>
-          </a:p>
-        </p:txBody>
-      </p:sp>
-      <p:sp>
-        <p:nvSpPr>
-          <p:cNvPr id="4" name="Rounded Rectangle 3"/>
+              <a:t>Feasibility, Viability &amp; Risk Management</a:t>
+            </a:r>
+          </a:p>
+        </p:txBody>
+      </p:sp>
+      <p:sp>
+        <p:nvSpPr>
+          <p:cNvPr id="4" name="TextBox 3"/>
+          <p:cNvSpPr txBox="1"/>
+          <p:nvPr/>
+        </p:nvSpPr>
+        <p:spPr>
+          <a:xfrm>
+            <a:off x="731520" y="1188720"/>
+            <a:ext cx="10698480" cy="320040"/>
+          </a:xfrm>
+          <a:prstGeom prst="rect">
+            <a:avLst/>
+          </a:prstGeom>
+          <a:noFill/>
+        </p:spPr>
+        <p:txBody>
+          <a:bodyPr wrap="square">
+            <a:spAutoFit/>
+          </a:bodyPr>
+          <a:lstStyle/>
+          <a:p>
+            <a:pPr>
+              <a:defRPr sz="1100">
+                <a:solidFill>
+                  <a:srgbClr val="64748B"/>
+                </a:solidFill>
+              </a:defRPr>
+            </a:pPr>
+            <a:r>
+              <a:t>Practical implementation strategy and proactive risk safeguards</a:t>
+            </a:r>
+          </a:p>
+        </p:txBody>
+      </p:sp>
+      <p:sp>
+        <p:nvSpPr>
+          <p:cNvPr id="5" name="Rounded Rectangle 4"/>
           <p:cNvSpPr/>
           <p:nvPr/>
         </p:nvSpPr>
         <p:spPr>
           <a:xfrm>
-            <a:off x="731520" y="1463040"/>
-            <a:ext cx="3383280" cy="1645920"/>
+            <a:off x="731520" y="1645920"/>
+            <a:ext cx="3291840" cy="1463040"/>
           </a:xfrm>
           <a:prstGeom prst="roundRect">
             <a:avLst/>
@@ -4521,7 +4622,7 @@
             <a:pPr algn="ctr">
               <a:defRPr sz="1100" b="1">
                 <a:solidFill>
-                  <a:srgbClr val="0F766E"/>
+                  <a:srgbClr val="0E7490"/>
                 </a:solidFill>
               </a:defRPr>
             </a:pPr>
@@ -4538,21 +4639,21 @@
               </a:defRPr>
             </a:pPr>
             <a:r>
-              <a:t>Built on mature, cloud-native open standards. Cross-platform compatibility with 100% browser accessibility and zero end-user maintenance.</a:t>
-            </a:r>
-          </a:p>
-        </p:txBody>
-      </p:sp>
-      <p:sp>
-        <p:nvSpPr>
-          <p:cNvPr id="5" name="Rounded Rectangle 4"/>
+              <a:t>Cloud-native, lightweight architecture. Fast response times with 100% browser compatibility.</a:t>
+            </a:r>
+          </a:p>
+        </p:txBody>
+      </p:sp>
+      <p:sp>
+        <p:nvSpPr>
+          <p:cNvPr id="6" name="Rounded Rectangle 5"/>
           <p:cNvSpPr/>
           <p:nvPr/>
         </p:nvSpPr>
         <p:spPr>
           <a:xfrm>
-            <a:off x="4389120" y="1463040"/>
-            <a:ext cx="3383280" cy="1645920"/>
+            <a:off x="4389120" y="1645920"/>
+            <a:ext cx="3291840" cy="1463040"/>
           </a:xfrm>
           <a:prstGeom prst="roundRect">
             <a:avLst/>
@@ -4587,7 +4688,7 @@
             <a:pPr algn="ctr">
               <a:defRPr sz="1100" b="1">
                 <a:solidFill>
-                  <a:srgbClr val="0F766E"/>
+                  <a:srgbClr val="0E7490"/>
                 </a:solidFill>
               </a:defRPr>
             </a:pPr>
@@ -4604,21 +4705,21 @@
               </a:defRPr>
             </a:pPr>
             <a:r>
-              <a:t>Zero initial hardware investment; leverages low-cost serverless hosting tiers; eliminates expensive proprietary ERP licensing.</a:t>
-            </a:r>
-          </a:p>
-        </p:txBody>
-      </p:sp>
-      <p:sp>
-        <p:nvSpPr>
-          <p:cNvPr id="6" name="Rounded Rectangle 5"/>
+              <a:t>Zero hardware setup required. Open infrastructure dramatically reduces total operational cost.</a:t>
+            </a:r>
+          </a:p>
+        </p:txBody>
+      </p:sp>
+      <p:sp>
+        <p:nvSpPr>
+          <p:cNvPr id="7" name="Rounded Rectangle 6"/>
           <p:cNvSpPr/>
           <p:nvPr/>
         </p:nvSpPr>
         <p:spPr>
           <a:xfrm>
-            <a:off x="8046720" y="1463040"/>
-            <a:ext cx="3383280" cy="1645920"/>
+            <a:off x="8046720" y="1645920"/>
+            <a:ext cx="3291840" cy="1463040"/>
           </a:xfrm>
           <a:prstGeom prst="roundRect">
             <a:avLst/>
@@ -4653,7 +4754,7 @@
             <a:pPr algn="ctr">
               <a:defRPr sz="1100" b="1">
                 <a:solidFill>
-                  <a:srgbClr val="0F766E"/>
+                  <a:srgbClr val="0E7490"/>
                 </a:solidFill>
               </a:defRPr>
             </a:pPr>
@@ -4670,14 +4771,14 @@
               </a:defRPr>
             </a:pPr>
             <a:r>
-              <a:t>Consumer-grade, minimalist 3-step workflow requires zero user training. Fast adoption for non-technical academic and corporate staff.</a:t>
+              <a:t>Clean, intuitive user interface. Non-technical staff can use the system with zero training.</a:t>
             </a:r>
           </a:p>
         </p:txBody>
       </p:sp>
       <p:graphicFrame>
         <p:nvGraphicFramePr>
-          <p:cNvPr id="7" name="Table 6"/>
+          <p:cNvPr id="8" name="Table 7"/>
           <p:cNvGraphicFramePr>
             <a:graphicFrameLocks noGrp="1"/>
           </p:cNvGraphicFramePr>
@@ -4685,7 +4786,7 @@
         </p:nvGraphicFramePr>
         <p:xfrm>
           <a:off x="731520" y="3291840"/>
-          <a:ext cx="10698480" cy="3108960"/>
+          <a:ext cx="10698480" cy="3017520"/>
         </p:xfrm>
         <a:graphic>
           <a:graphicData uri="http://schemas.openxmlformats.org/drawingml/2006/table">
@@ -4695,11 +4796,10 @@
               </a:tblPr>
               <a:tblGrid>
                 <a:gridCol w="2926080"/>
-                <a:gridCol w="1463040"/>
-                <a:gridCol w="1463040"/>
-                <a:gridCol w="4846320"/>
+                <a:gridCol w="2011680"/>
+                <a:gridCol w="5760720"/>
               </a:tblGrid>
-              <a:tr h="621792">
+              <a:tr h="754380">
                 <a:tc>
                   <a:txBody>
                     <a:bodyPr/>
@@ -4713,7 +4813,7 @@
                         </a:defRPr>
                       </a:pPr>
                       <a:r>
-                        <a:t>Potential Risk / Challenge</a:t>
+                        <a:t>Potential Challenge</a:t>
                       </a:r>
                     </a:p>
                   </a:txBody>
@@ -4736,30 +4836,7 @@
                         </a:defRPr>
                       </a:pPr>
                       <a:r>
-                        <a:t>Probability</a:t>
-                      </a:r>
-                    </a:p>
-                  </a:txBody>
-                  <a:tcPr>
-                    <a:solidFill>
-                      <a:srgbClr val="0F172A"/>
-                    </a:solidFill>
-                  </a:tcPr>
-                </a:tc>
-                <a:tc>
-                  <a:txBody>
-                    <a:bodyPr/>
-                    <a:lstStyle/>
-                    <a:p>
-                      <a:pPr>
-                        <a:defRPr sz="1000" b="1">
-                          <a:solidFill>
-                            <a:srgbClr val="FFFFFF"/>
-                          </a:solidFill>
-                        </a:defRPr>
-                      </a:pPr>
-                      <a:r>
-                        <a:t>Impact</a:t>
+                        <a:t>Impact Level</a:t>
                       </a:r>
                     </a:p>
                   </a:txBody>
@@ -4793,21 +4870,21 @@
                   </a:tcPr>
                 </a:tc>
               </a:tr>
-              <a:tr h="621792">
+              <a:tr h="754380">
                 <a:tc>
                   <a:txBody>
                     <a:bodyPr/>
                     <a:lstStyle/>
                     <a:p>
                       <a:pPr>
-                        <a:defRPr sz="950">
+                        <a:defRPr sz="1000">
                           <a:solidFill>
                             <a:srgbClr val="1E293B"/>
                           </a:solidFill>
                         </a:defRPr>
                       </a:pPr>
                       <a:r>
-                        <a:t>Concurrent Leave Applications</a:t>
+                        <a:t>Simultaneous Submissions</a:t>
                       </a:r>
                     </a:p>
                   </a:txBody>
@@ -4823,7 +4900,149 @@
                     <a:lstStyle/>
                     <a:p>
                       <a:pPr>
-                        <a:defRPr sz="950">
+                        <a:defRPr sz="1000">
+                          <a:solidFill>
+                            <a:srgbClr val="1E293B"/>
+                          </a:solidFill>
+                        </a:defRPr>
+                      </a:pPr>
+                      <a:r>
+                        <a:t>Medium</a:t>
+                      </a:r>
+                    </a:p>
+                  </a:txBody>
+                  <a:tcPr>
+                    <a:solidFill>
+                      <a:srgbClr val="F8FAFC"/>
+                    </a:solidFill>
+                  </a:tcPr>
+                </a:tc>
+                <a:tc>
+                  <a:txBody>
+                    <a:bodyPr/>
+                    <a:lstStyle/>
+                    <a:p>
+                      <a:pPr>
+                        <a:defRPr sz="1000">
+                          <a:solidFill>
+                            <a:srgbClr val="1E293B"/>
+                          </a:solidFill>
+                        </a:defRPr>
+                      </a:pPr>
+                      <a:r>
+                        <a:t>Database balance locking ensures balances cannot drop below zero.</a:t>
+                      </a:r>
+                    </a:p>
+                  </a:txBody>
+                  <a:tcPr>
+                    <a:solidFill>
+                      <a:srgbClr val="F8FAFC"/>
+                    </a:solidFill>
+                  </a:tcPr>
+                </a:tc>
+              </a:tr>
+              <a:tr h="754380">
+                <a:tc>
+                  <a:txBody>
+                    <a:bodyPr/>
+                    <a:lstStyle/>
+                    <a:p>
+                      <a:pPr>
+                        <a:defRPr sz="1000">
+                          <a:solidFill>
+                            <a:srgbClr val="1E293B"/>
+                          </a:solidFill>
+                        </a:defRPr>
+                      </a:pPr>
+                      <a:r>
+                        <a:t>Unauthorized Access</a:t>
+                      </a:r>
+                    </a:p>
+                  </a:txBody>
+                  <a:tcPr>
+                    <a:solidFill>
+                      <a:srgbClr val="FFFFFF"/>
+                    </a:solidFill>
+                  </a:tcPr>
+                </a:tc>
+                <a:tc>
+                  <a:txBody>
+                    <a:bodyPr/>
+                    <a:lstStyle/>
+                    <a:p>
+                      <a:pPr>
+                        <a:defRPr sz="1000">
+                          <a:solidFill>
+                            <a:srgbClr val="1E293B"/>
+                          </a:solidFill>
+                        </a:defRPr>
+                      </a:pPr>
+                      <a:r>
+                        <a:t>High</a:t>
+                      </a:r>
+                    </a:p>
+                  </a:txBody>
+                  <a:tcPr>
+                    <a:solidFill>
+                      <a:srgbClr val="FFFFFF"/>
+                    </a:solidFill>
+                  </a:tcPr>
+                </a:tc>
+                <a:tc>
+                  <a:txBody>
+                    <a:bodyPr/>
+                    <a:lstStyle/>
+                    <a:p>
+                      <a:pPr>
+                        <a:defRPr sz="1000">
+                          <a:solidFill>
+                            <a:srgbClr val="1E293B"/>
+                          </a:solidFill>
+                        </a:defRPr>
+                      </a:pPr>
+                      <a:r>
+                        <a:t>Strict server-side role verification protects all sensitive operations.</a:t>
+                      </a:r>
+                    </a:p>
+                  </a:txBody>
+                  <a:tcPr>
+                    <a:solidFill>
+                      <a:srgbClr val="FFFFFF"/>
+                    </a:solidFill>
+                  </a:tcPr>
+                </a:tc>
+              </a:tr>
+              <a:tr h="754380">
+                <a:tc>
+                  <a:txBody>
+                    <a:bodyPr/>
+                    <a:lstStyle/>
+                    <a:p>
+                      <a:pPr>
+                        <a:defRPr sz="1000">
+                          <a:solidFill>
+                            <a:srgbClr val="1E293B"/>
+                          </a:solidFill>
+                        </a:defRPr>
+                      </a:pPr>
+                      <a:r>
+                        <a:t>User Reluctance to Adopt</a:t>
+                      </a:r>
+                    </a:p>
+                  </a:txBody>
+                  <a:tcPr>
+                    <a:solidFill>
+                      <a:srgbClr val="F8FAFC"/>
+                    </a:solidFill>
+                  </a:tcPr>
+                </a:tc>
+                <a:tc>
+                  <a:txBody>
+                    <a:bodyPr/>
+                    <a:lstStyle/>
+                    <a:p>
+                      <a:pPr>
+                        <a:defRPr sz="1000">
                           <a:solidFill>
                             <a:srgbClr val="1E293B"/>
                           </a:solidFill>
@@ -4846,325 +5065,20 @@
                     <a:lstStyle/>
                     <a:p>
                       <a:pPr>
-                        <a:defRPr sz="950">
+                        <a:defRPr sz="1000">
                           <a:solidFill>
                             <a:srgbClr val="1E293B"/>
                           </a:solidFill>
                         </a:defRPr>
                       </a:pPr>
                       <a:r>
-                        <a:t>Medium</a:t>
+                        <a:t>Simple 3-click application flow designed for immediate ease of use.</a:t>
                       </a:r>
                     </a:p>
                   </a:txBody>
                   <a:tcPr>
                     <a:solidFill>
                       <a:srgbClr val="F8FAFC"/>
-                    </a:solidFill>
-                  </a:tcPr>
-                </a:tc>
-                <a:tc>
-                  <a:txBody>
-                    <a:bodyPr/>
-                    <a:lstStyle/>
-                    <a:p>
-                      <a:pPr>
-                        <a:defRPr sz="950">
-                          <a:solidFill>
-                            <a:srgbClr val="1E293B"/>
-                          </a:solidFill>
-                        </a:defRPr>
-                      </a:pPr>
-                      <a:r>
-                        <a:t>Atomic database transactions ensure leave balance cannot drop below zero during simultaneous requests.</a:t>
-                      </a:r>
-                    </a:p>
-                  </a:txBody>
-                  <a:tcPr>
-                    <a:solidFill>
-                      <a:srgbClr val="F8FAFC"/>
-                    </a:solidFill>
-                  </a:tcPr>
-                </a:tc>
-              </a:tr>
-              <a:tr h="621792">
-                <a:tc>
-                  <a:txBody>
-                    <a:bodyPr/>
-                    <a:lstStyle/>
-                    <a:p>
-                      <a:pPr>
-                        <a:defRPr sz="950">
-                          <a:solidFill>
-                            <a:srgbClr val="1E293B"/>
-                          </a:solidFill>
-                        </a:defRPr>
-                      </a:pPr>
-                      <a:r>
-                        <a:t>Unauthorized Privilege Access</a:t>
-                      </a:r>
-                    </a:p>
-                  </a:txBody>
-                  <a:tcPr>
-                    <a:solidFill>
-                      <a:srgbClr val="FFFFFF"/>
-                    </a:solidFill>
-                  </a:tcPr>
-                </a:tc>
-                <a:tc>
-                  <a:txBody>
-                    <a:bodyPr/>
-                    <a:lstStyle/>
-                    <a:p>
-                      <a:pPr>
-                        <a:defRPr sz="950">
-                          <a:solidFill>
-                            <a:srgbClr val="1E293B"/>
-                          </a:solidFill>
-                        </a:defRPr>
-                      </a:pPr>
-                      <a:r>
-                        <a:t>Low</a:t>
-                      </a:r>
-                    </a:p>
-                  </a:txBody>
-                  <a:tcPr>
-                    <a:solidFill>
-                      <a:srgbClr val="FFFFFF"/>
-                    </a:solidFill>
-                  </a:tcPr>
-                </a:tc>
-                <a:tc>
-                  <a:txBody>
-                    <a:bodyPr/>
-                    <a:lstStyle/>
-                    <a:p>
-                      <a:pPr>
-                        <a:defRPr sz="950">
-                          <a:solidFill>
-                            <a:srgbClr val="1E293B"/>
-                          </a:solidFill>
-                        </a:defRPr>
-                      </a:pPr>
-                      <a:r>
-                        <a:t>Critical</a:t>
-                      </a:r>
-                    </a:p>
-                  </a:txBody>
-                  <a:tcPr>
-                    <a:solidFill>
-                      <a:srgbClr val="FFFFFF"/>
-                    </a:solidFill>
-                  </a:tcPr>
-                </a:tc>
-                <a:tc>
-                  <a:txBody>
-                    <a:bodyPr/>
-                    <a:lstStyle/>
-                    <a:p>
-                      <a:pPr>
-                        <a:defRPr sz="950">
-                          <a:solidFill>
-                            <a:srgbClr val="1E293B"/>
-                          </a:solidFill>
-                        </a:defRPr>
-                      </a:pPr>
-                      <a:r>
-                        <a:t>Strict server-side cryptographic token verification on every endpoint; prevents role spoofing.</a:t>
-                      </a:r>
-                    </a:p>
-                  </a:txBody>
-                  <a:tcPr>
-                    <a:solidFill>
-                      <a:srgbClr val="FFFFFF"/>
-                    </a:solidFill>
-                  </a:tcPr>
-                </a:tc>
-              </a:tr>
-              <a:tr h="621792">
-                <a:tc>
-                  <a:txBody>
-                    <a:bodyPr/>
-                    <a:lstStyle/>
-                    <a:p>
-                      <a:pPr>
-                        <a:defRPr sz="950">
-                          <a:solidFill>
-                            <a:srgbClr val="1E293B"/>
-                          </a:solidFill>
-                        </a:defRPr>
-                      </a:pPr>
-                      <a:r>
-                        <a:t>Server Latency / High Volume</a:t>
-                      </a:r>
-                    </a:p>
-                  </a:txBody>
-                  <a:tcPr>
-                    <a:solidFill>
-                      <a:srgbClr val="F8FAFC"/>
-                    </a:solidFill>
-                  </a:tcPr>
-                </a:tc>
-                <a:tc>
-                  <a:txBody>
-                    <a:bodyPr/>
-                    <a:lstStyle/>
-                    <a:p>
-                      <a:pPr>
-                        <a:defRPr sz="950">
-                          <a:solidFill>
-                            <a:srgbClr val="1E293B"/>
-                          </a:solidFill>
-                        </a:defRPr>
-                      </a:pPr>
-                      <a:r>
-                        <a:t>Low</a:t>
-                      </a:r>
-                    </a:p>
-                  </a:txBody>
-                  <a:tcPr>
-                    <a:solidFill>
-                      <a:srgbClr val="F8FAFC"/>
-                    </a:solidFill>
-                  </a:tcPr>
-                </a:tc>
-                <a:tc>
-                  <a:txBody>
-                    <a:bodyPr/>
-                    <a:lstStyle/>
-                    <a:p>
-                      <a:pPr>
-                        <a:defRPr sz="950">
-                          <a:solidFill>
-                            <a:srgbClr val="1E293B"/>
-                          </a:solidFill>
-                        </a:defRPr>
-                      </a:pPr>
-                      <a:r>
-                        <a:t>Medium</a:t>
-                      </a:r>
-                    </a:p>
-                  </a:txBody>
-                  <a:tcPr>
-                    <a:solidFill>
-                      <a:srgbClr val="F8FAFC"/>
-                    </a:solidFill>
-                  </a:tcPr>
-                </a:tc>
-                <a:tc>
-                  <a:txBody>
-                    <a:bodyPr/>
-                    <a:lstStyle/>
-                    <a:p>
-                      <a:pPr>
-                        <a:defRPr sz="950">
-                          <a:solidFill>
-                            <a:srgbClr val="1E293B"/>
-                          </a:solidFill>
-                        </a:defRPr>
-                      </a:pPr>
-                      <a:r>
-                        <a:t>Stateless cloud API architecture with dynamic auto-scaling to handle peak-period request surges.</a:t>
-                      </a:r>
-                    </a:p>
-                  </a:txBody>
-                  <a:tcPr>
-                    <a:solidFill>
-                      <a:srgbClr val="F8FAFC"/>
-                    </a:solidFill>
-                  </a:tcPr>
-                </a:tc>
-              </a:tr>
-              <a:tr h="621792">
-                <a:tc>
-                  <a:txBody>
-                    <a:bodyPr/>
-                    <a:lstStyle/>
-                    <a:p>
-                      <a:pPr>
-                        <a:defRPr sz="950">
-                          <a:solidFill>
-                            <a:srgbClr val="1E293B"/>
-                          </a:solidFill>
-                        </a:defRPr>
-                      </a:pPr>
-                      <a:r>
-                        <a:t>User Reluctance to Adopt</a:t>
-                      </a:r>
-                    </a:p>
-                  </a:txBody>
-                  <a:tcPr>
-                    <a:solidFill>
-                      <a:srgbClr val="FFFFFF"/>
-                    </a:solidFill>
-                  </a:tcPr>
-                </a:tc>
-                <a:tc>
-                  <a:txBody>
-                    <a:bodyPr/>
-                    <a:lstStyle/>
-                    <a:p>
-                      <a:pPr>
-                        <a:defRPr sz="950">
-                          <a:solidFill>
-                            <a:srgbClr val="1E293B"/>
-                          </a:solidFill>
-                        </a:defRPr>
-                      </a:pPr>
-                      <a:r>
-                        <a:t>Medium</a:t>
-                      </a:r>
-                    </a:p>
-                  </a:txBody>
-                  <a:tcPr>
-                    <a:solidFill>
-                      <a:srgbClr val="FFFFFF"/>
-                    </a:solidFill>
-                  </a:tcPr>
-                </a:tc>
-                <a:tc>
-                  <a:txBody>
-                    <a:bodyPr/>
-                    <a:lstStyle/>
-                    <a:p>
-                      <a:pPr>
-                        <a:defRPr sz="950">
-                          <a:solidFill>
-                            <a:srgbClr val="1E293B"/>
-                          </a:solidFill>
-                        </a:defRPr>
-                      </a:pPr>
-                      <a:r>
-                        <a:t>Low</a:t>
-                      </a:r>
-                    </a:p>
-                  </a:txBody>
-                  <a:tcPr>
-                    <a:solidFill>
-                      <a:srgbClr val="FFFFFF"/>
-                    </a:solidFill>
-                  </a:tcPr>
-                </a:tc>
-                <a:tc>
-                  <a:txBody>
-                    <a:bodyPr/>
-                    <a:lstStyle/>
-                    <a:p>
-                      <a:pPr>
-                        <a:defRPr sz="950">
-                          <a:solidFill>
-                            <a:srgbClr val="1E293B"/>
-                          </a:solidFill>
-                        </a:defRPr>
-                      </a:pPr>
-                      <a:r>
-                        <a:t>Clean, frictionless interface with self-explanatory balances, eliminating technical hurdles for staff.</a:t>
-                      </a:r>
-                    </a:p>
-                  </a:txBody>
-                  <a:tcPr>
-                    <a:solidFill>
-                      <a:srgbClr val="FFFFFF"/>
                     </a:solidFill>
                   </a:tcPr>
                 </a:tc>
@@ -5200,7 +5114,7 @@
         <p:spPr>
           <a:xfrm>
             <a:off x="731520" y="365760"/>
-            <a:ext cx="10698480" cy="365760"/>
+            <a:ext cx="10698480" cy="320040"/>
           </a:xfrm>
           <a:prstGeom prst="rect">
             <a:avLst/>
@@ -5214,14 +5128,14 @@
           <a:lstStyle/>
           <a:p>
             <a:pPr>
-              <a:defRPr sz="1100" b="1">
-                <a:solidFill>
-                  <a:srgbClr val="0F766E"/>
-                </a:solidFill>
-              </a:defRPr>
-            </a:pPr>
-            <a:r>
-              <a:t>SMART INDIA HACKATHON 2024 / 2025</a:t>
+              <a:defRPr sz="1000" b="1">
+                <a:solidFill>
+                  <a:srgbClr val="0E7490"/>
+                </a:solidFill>
+              </a:defRPr>
+            </a:pPr>
+            <a:r>
+              <a:t>SIH PRESENTATION  |  SLIDE 5 OF 6</a:t>
             </a:r>
           </a:p>
         </p:txBody>
@@ -5235,7 +5149,7 @@
         <p:spPr>
           <a:xfrm>
             <a:off x="731520" y="640080"/>
-            <a:ext cx="10698480" cy="731520"/>
+            <a:ext cx="10698480" cy="548640"/>
           </a:xfrm>
           <a:prstGeom prst="rect">
             <a:avLst/>
@@ -5249,27 +5163,62 @@
           <a:lstStyle/>
           <a:p>
             <a:pPr>
-              <a:defRPr sz="2400" b="1">
+              <a:defRPr sz="2200" b="1">
                 <a:solidFill>
                   <a:srgbClr val="0F172A"/>
                 </a:solidFill>
               </a:defRPr>
             </a:pPr>
             <a:r>
-              <a:t>Slide 5: Impact, Organizational Benefits &amp; Scalability</a:t>
-            </a:r>
-          </a:p>
-        </p:txBody>
-      </p:sp>
-      <p:sp>
-        <p:nvSpPr>
-          <p:cNvPr id="4" name="Rounded Rectangle 3"/>
+              <a:t>Impact, Organizational Benefits &amp; Scalability</a:t>
+            </a:r>
+          </a:p>
+        </p:txBody>
+      </p:sp>
+      <p:sp>
+        <p:nvSpPr>
+          <p:cNvPr id="4" name="TextBox 3"/>
+          <p:cNvSpPr txBox="1"/>
+          <p:nvPr/>
+        </p:nvSpPr>
+        <p:spPr>
+          <a:xfrm>
+            <a:off x="731520" y="1188720"/>
+            <a:ext cx="10698480" cy="320040"/>
+          </a:xfrm>
+          <a:prstGeom prst="rect">
+            <a:avLst/>
+          </a:prstGeom>
+          <a:noFill/>
+        </p:spPr>
+        <p:txBody>
+          <a:bodyPr wrap="square">
+            <a:spAutoFit/>
+          </a:bodyPr>
+          <a:lstStyle/>
+          <a:p>
+            <a:pPr>
+              <a:defRPr sz="1100">
+                <a:solidFill>
+                  <a:srgbClr val="64748B"/>
+                </a:solidFill>
+              </a:defRPr>
+            </a:pPr>
+            <a:r>
+              <a:t>Measurable productivity enhancements for modern teams</a:t>
+            </a:r>
+          </a:p>
+        </p:txBody>
+      </p:sp>
+      <p:sp>
+        <p:nvSpPr>
+          <p:cNvPr id="5" name="Rounded Rectangle 4"/>
           <p:cNvSpPr/>
           <p:nvPr/>
         </p:nvSpPr>
         <p:spPr>
           <a:xfrm>
-            <a:off x="731520" y="1463040"/>
+            <a:off x="731520" y="1645920"/>
             <a:ext cx="2468880" cy="1463040"/>
           </a:xfrm>
           <a:prstGeom prst="roundRect">
@@ -5280,7 +5229,7 @@
           </a:solidFill>
           <a:ln>
             <a:solidFill>
-              <a:srgbClr val="0F766E"/>
+              <a:srgbClr val="0E7490"/>
             </a:solidFill>
           </a:ln>
         </p:spPr>
@@ -5305,12 +5254,12 @@
             <a:pPr algn="ctr">
               <a:defRPr sz="2800" b="1">
                 <a:solidFill>
-                  <a:srgbClr val="0F766E"/>
-                </a:solidFill>
-              </a:defRPr>
-            </a:pPr>
-            <a:r>
-              <a:t>85%</a:t>
+                  <a:srgbClr val="0E7490"/>
+                </a:solidFill>
+              </a:defRPr>
+            </a:pPr>
+            <a:r>
+              <a:t>90%</a:t>
             </a:r>
           </a:p>
           <a:p>
@@ -5322,7 +5271,7 @@
               </a:defRPr>
             </a:pPr>
             <a:r>
-              <a:t>Turnaround Reduction</a:t>
+              <a:t>Faster Turnaround</a:t>
             </a:r>
           </a:p>
           <a:p>
@@ -5334,20 +5283,20 @@
               </a:defRPr>
             </a:pPr>
             <a:r>
-              <a:t>Approvals completed in minutes rather than days.</a:t>
-            </a:r>
-          </a:p>
-        </p:txBody>
-      </p:sp>
-      <p:sp>
-        <p:nvSpPr>
-          <p:cNvPr id="5" name="Rounded Rectangle 4"/>
+              <a:t>Approvals in minutes, not days</a:t>
+            </a:r>
+          </a:p>
+        </p:txBody>
+      </p:sp>
+      <p:sp>
+        <p:nvSpPr>
+          <p:cNvPr id="6" name="Rounded Rectangle 5"/>
           <p:cNvSpPr/>
           <p:nvPr/>
         </p:nvSpPr>
         <p:spPr>
           <a:xfrm>
-            <a:off x="3474720" y="1463040"/>
+            <a:off x="3474720" y="1645920"/>
             <a:ext cx="2468880" cy="1463040"/>
           </a:xfrm>
           <a:prstGeom prst="roundRect">
@@ -5358,7 +5307,7 @@
           </a:solidFill>
           <a:ln>
             <a:solidFill>
-              <a:srgbClr val="0F766E"/>
+              <a:srgbClr val="0E7490"/>
             </a:solidFill>
           </a:ln>
         </p:spPr>
@@ -5383,7 +5332,7 @@
             <a:pPr algn="ctr">
               <a:defRPr sz="2800" b="1">
                 <a:solidFill>
-                  <a:srgbClr val="0F766E"/>
+                  <a:srgbClr val="0E7490"/>
                 </a:solidFill>
               </a:defRPr>
             </a:pPr>
@@ -5400,7 +5349,7 @@
               </a:defRPr>
             </a:pPr>
             <a:r>
-              <a:t>Calculation Accuracy</a:t>
+              <a:t>Paperless System</a:t>
             </a:r>
           </a:p>
           <a:p>
@@ -5412,20 +5361,20 @@
               </a:defRPr>
             </a:pPr>
             <a:r>
-              <a:t>Zero human error in tracking remaining quotas.</a:t>
-            </a:r>
-          </a:p>
-        </p:txBody>
-      </p:sp>
-      <p:sp>
-        <p:nvSpPr>
-          <p:cNvPr id="6" name="Rounded Rectangle 5"/>
+              <a:t>Zero manual register paperwork</a:t>
+            </a:r>
+          </a:p>
+        </p:txBody>
+      </p:sp>
+      <p:sp>
+        <p:nvSpPr>
+          <p:cNvPr id="7" name="Rounded Rectangle 6"/>
           <p:cNvSpPr/>
           <p:nvPr/>
         </p:nvSpPr>
         <p:spPr>
           <a:xfrm>
-            <a:off x="6217920" y="1463040"/>
+            <a:off x="6217920" y="1645920"/>
             <a:ext cx="2468880" cy="1463040"/>
           </a:xfrm>
           <a:prstGeom prst="roundRect">
@@ -5436,7 +5385,7 @@
           </a:solidFill>
           <a:ln>
             <a:solidFill>
-              <a:srgbClr val="0F766E"/>
+              <a:srgbClr val="0E7490"/>
             </a:solidFill>
           </a:ln>
         </p:spPr>
@@ -5461,12 +5410,12 @@
             <a:pPr algn="ctr">
               <a:defRPr sz="2800" b="1">
                 <a:solidFill>
-                  <a:srgbClr val="0F766E"/>
-                </a:solidFill>
-              </a:defRPr>
-            </a:pPr>
-            <a:r>
-              <a:t>0</a:t>
+                  <a:srgbClr val="0E7490"/>
+                </a:solidFill>
+              </a:defRPr>
+            </a:pPr>
+            <a:r>
+              <a:t>0%</a:t>
             </a:r>
           </a:p>
           <a:p>
@@ -5478,7 +5427,7 @@
               </a:defRPr>
             </a:pPr>
             <a:r>
-              <a:t>Paper Footprint</a:t>
+              <a:t>Calculation Errors</a:t>
             </a:r>
           </a:p>
           <a:p>
@@ -5490,20 +5439,20 @@
               </a:defRPr>
             </a:pPr>
             <a:r>
-              <a:t>Complete paperless transition with audit records.</a:t>
-            </a:r>
-          </a:p>
-        </p:txBody>
-      </p:sp>
-      <p:sp>
-        <p:nvSpPr>
-          <p:cNvPr id="7" name="Rounded Rectangle 6"/>
+              <a:t>Automated leave quota deduction</a:t>
+            </a:r>
+          </a:p>
+        </p:txBody>
+      </p:sp>
+      <p:sp>
+        <p:nvSpPr>
+          <p:cNvPr id="8" name="Rounded Rectangle 7"/>
           <p:cNvSpPr/>
           <p:nvPr/>
         </p:nvSpPr>
         <p:spPr>
           <a:xfrm>
-            <a:off x="8961120" y="1463040"/>
+            <a:off x="8961120" y="1645920"/>
             <a:ext cx="2468880" cy="1463040"/>
           </a:xfrm>
           <a:prstGeom prst="roundRect">
@@ -5514,7 +5463,7 @@
           </a:solidFill>
           <a:ln>
             <a:solidFill>
-              <a:srgbClr val="0F766E"/>
+              <a:srgbClr val="0E7490"/>
             </a:solidFill>
           </a:ln>
         </p:spPr>
@@ -5539,12 +5488,12 @@
             <a:pPr algn="ctr">
               <a:defRPr sz="2800" b="1">
                 <a:solidFill>
-                  <a:srgbClr val="0F766E"/>
-                </a:solidFill>
-              </a:defRPr>
-            </a:pPr>
-            <a:r>
-              <a:t>100%</a:t>
+                  <a:srgbClr val="0E7490"/>
+                </a:solidFill>
+              </a:defRPr>
+            </a:pPr>
+            <a:r>
+              <a:t>Live</a:t>
             </a:r>
           </a:p>
           <a:p>
@@ -5556,7 +5505,7 @@
               </a:defRPr>
             </a:pPr>
             <a:r>
-              <a:t>Visibility</a:t>
+              <a:t>Team Visibility</a:t>
             </a:r>
           </a:p>
           <a:p>
@@ -5568,21 +5517,21 @@
               </a:defRPr>
             </a:pPr>
             <a:r>
-              <a:t>Real-time departmental headcount &amp; leave monitoring.</a:t>
-            </a:r>
-          </a:p>
-        </p:txBody>
-      </p:sp>
-      <p:sp>
-        <p:nvSpPr>
-          <p:cNvPr id="8" name="Rounded Rectangle 7"/>
+              <a:t>Real-time on-leave headcounts</a:t>
+            </a:r>
+          </a:p>
+        </p:txBody>
+      </p:sp>
+      <p:sp>
+        <p:nvSpPr>
+          <p:cNvPr id="9" name="Rounded Rectangle 8"/>
           <p:cNvSpPr/>
           <p:nvPr/>
         </p:nvSpPr>
         <p:spPr>
           <a:xfrm>
-            <a:off x="731520" y="3108960"/>
-            <a:ext cx="5212080" cy="3291840"/>
+            <a:off x="731520" y="3291840"/>
+            <a:ext cx="5120640" cy="3017520"/>
           </a:xfrm>
           <a:prstGeom prst="roundRect">
             <a:avLst/>
@@ -5617,12 +5566,12 @@
             <a:pPr algn="ctr">
               <a:defRPr sz="1200" b="1">
                 <a:solidFill>
-                  <a:srgbClr val="0F766E"/>
-                </a:solidFill>
-              </a:defRPr>
-            </a:pPr>
-            <a:r>
-              <a:t>TARGET BENEFICIARIES &amp; SECTOR IMPACT</a:t>
+                  <a:srgbClr val="0E7490"/>
+                </a:solidFill>
+              </a:defRPr>
+            </a:pPr>
+            <a:r>
+              <a:t>TARGET BENEFICIARIES</a:t>
             </a:r>
           </a:p>
           <a:p>
@@ -5634,7 +5583,7 @@
               </a:defRPr>
             </a:pPr>
             <a:r>
-              <a:t>• Higher Educational Institutions: Department heads, faculty, lab assistants, and administrative staff.</a:t>
+              <a:t>• Colleges &amp; Universities: Faculty, departments &amp; admin offices</a:t>
             </a:r>
           </a:p>
           <a:p>
@@ -5646,7 +5595,7 @@
               </a:defRPr>
             </a:pPr>
             <a:r>
-              <a:t>• Small &amp; Medium Enterprises (SMEs): Growing companies requiring enterprise-grade leave governance without high ERP costs.</a:t>
+              <a:t>• Small &amp; Medium Businesses: Cost-effective, modern leave tracking</a:t>
             </a:r>
           </a:p>
           <a:p>
@@ -5658,21 +5607,21 @@
               </a:defRPr>
             </a:pPr>
             <a:r>
-              <a:t>• Healthcare &amp; Critical Operations: Teams requiring strict minimum on-duty staffing thresholds to avoid service disruptions.</a:t>
-            </a:r>
-          </a:p>
-        </p:txBody>
-      </p:sp>
-      <p:sp>
-        <p:nvSpPr>
-          <p:cNvPr id="9" name="Rounded Rectangle 8"/>
+              <a:t>• Healthcare &amp; Field Operations: Ensures minimum required on-duty staff</a:t>
+            </a:r>
+          </a:p>
+        </p:txBody>
+      </p:sp>
+      <p:sp>
+        <p:nvSpPr>
+          <p:cNvPr id="10" name="Rounded Rectangle 9"/>
           <p:cNvSpPr/>
           <p:nvPr/>
         </p:nvSpPr>
         <p:spPr>
           <a:xfrm>
-            <a:off x="6217920" y="3108960"/>
-            <a:ext cx="5212080" cy="3291840"/>
+            <a:off x="6217920" y="3291840"/>
+            <a:ext cx="5212080" cy="3017520"/>
           </a:xfrm>
           <a:prstGeom prst="roundRect">
             <a:avLst/>
@@ -5707,12 +5656,12 @@
             <a:pPr algn="ctr">
               <a:defRPr sz="1200" b="1">
                 <a:solidFill>
-                  <a:srgbClr val="0F766E"/>
-                </a:solidFill>
-              </a:defRPr>
-            </a:pPr>
-            <a:r>
-              <a:t>COMMERCIALIZATION &amp; HORIZONTAL SCALING</a:t>
+                  <a:srgbClr val="0E7490"/>
+                </a:solidFill>
+              </a:defRPr>
+            </a:pPr>
+            <a:r>
+              <a:t>SCALABILITY &amp; EXPANSION</a:t>
             </a:r>
           </a:p>
           <a:p>
@@ -5724,7 +5673,7 @@
               </a:defRPr>
             </a:pPr>
             <a:r>
-              <a:t>✔ Multi-Tenant Cloud Architecture: Readily extensible to serve multiple colleges or corporate branches on a shared, secure infrastructure.</a:t>
+              <a:t>✔ Multi-Branch Ready: Easily manages multiple departments or campuses</a:t>
             </a:r>
           </a:p>
           <a:p>
@@ -5736,7 +5685,7 @@
               </a:defRPr>
             </a:pPr>
             <a:r>
-              <a:t>✔ Modular Policy Configuration: Easily adapts to custom organizational rules: carry-forward leaves, probationary restrictions, and regional holidays.</a:t>
+              <a:t>✔ Custom Leave Policies: Configurable yearly quotas &amp; leave categories</a:t>
             </a:r>
           </a:p>
           <a:p>
@@ -5748,7 +5697,7 @@
               </a:defRPr>
             </a:pPr>
             <a:r>
-              <a:t>✔ Low-Cost SaaS Business Model: Affordable per-user/per-month pricing model delivering high ROI and sustainable recurring revenue.</a:t>
+              <a:t>✔ Affordable SaaS Model: Minimal hosting cost with high return on investment</a:t>
             </a:r>
           </a:p>
         </p:txBody>
@@ -5780,7 +5729,7 @@
         <p:spPr>
           <a:xfrm>
             <a:off x="731520" y="365760"/>
-            <a:ext cx="10698480" cy="365760"/>
+            <a:ext cx="10698480" cy="320040"/>
           </a:xfrm>
           <a:prstGeom prst="rect">
             <a:avLst/>
@@ -5794,14 +5743,14 @@
           <a:lstStyle/>
           <a:p>
             <a:pPr>
-              <a:defRPr sz="1100" b="1">
-                <a:solidFill>
-                  <a:srgbClr val="0F766E"/>
-                </a:solidFill>
-              </a:defRPr>
-            </a:pPr>
-            <a:r>
-              <a:t>SMART INDIA HACKATHON 2024 / 2025</a:t>
+              <a:defRPr sz="1000" b="1">
+                <a:solidFill>
+                  <a:srgbClr val="0E7490"/>
+                </a:solidFill>
+              </a:defRPr>
+            </a:pPr>
+            <a:r>
+              <a:t>SIH PRESENTATION  |  SLIDE 6 OF 6</a:t>
             </a:r>
           </a:p>
         </p:txBody>
@@ -5815,7 +5764,7 @@
         <p:spPr>
           <a:xfrm>
             <a:off x="731520" y="640080"/>
-            <a:ext cx="10698480" cy="731520"/>
+            <a:ext cx="10698480" cy="548640"/>
           </a:xfrm>
           <a:prstGeom prst="rect">
             <a:avLst/>
@@ -5829,28 +5778,63 @@
           <a:lstStyle/>
           <a:p>
             <a:pPr>
-              <a:defRPr sz="2400" b="1">
+              <a:defRPr sz="2200" b="1">
                 <a:solidFill>
                   <a:srgbClr val="0F172A"/>
                 </a:solidFill>
               </a:defRPr>
             </a:pPr>
             <a:r>
-              <a:t>Slide 6: Future Scope, Strategic Roadmap &amp; Conclusion</a:t>
-            </a:r>
-          </a:p>
-        </p:txBody>
-      </p:sp>
-      <p:sp>
-        <p:nvSpPr>
-          <p:cNvPr id="4" name="Rounded Rectangle 3"/>
+              <a:t>Future Scope, Roadmap &amp; Conclusion</a:t>
+            </a:r>
+          </a:p>
+        </p:txBody>
+      </p:sp>
+      <p:sp>
+        <p:nvSpPr>
+          <p:cNvPr id="4" name="TextBox 3"/>
+          <p:cNvSpPr txBox="1"/>
+          <p:nvPr/>
+        </p:nvSpPr>
+        <p:spPr>
+          <a:xfrm>
+            <a:off x="731520" y="1188720"/>
+            <a:ext cx="10698480" cy="320040"/>
+          </a:xfrm>
+          <a:prstGeom prst="rect">
+            <a:avLst/>
+          </a:prstGeom>
+          <a:noFill/>
+        </p:spPr>
+        <p:txBody>
+          <a:bodyPr wrap="square">
+            <a:spAutoFit/>
+          </a:bodyPr>
+          <a:lstStyle/>
+          <a:p>
+            <a:pPr>
+              <a:defRPr sz="1100">
+                <a:solidFill>
+                  <a:srgbClr val="64748B"/>
+                </a:solidFill>
+              </a:defRPr>
+            </a:pPr>
+            <a:r>
+              <a:t>Clear expansion path toward an intelligent workplace assistant</a:t>
+            </a:r>
+          </a:p>
+        </p:txBody>
+      </p:sp>
+      <p:sp>
+        <p:nvSpPr>
+          <p:cNvPr id="5" name="Rounded Rectangle 4"/>
           <p:cNvSpPr/>
           <p:nvPr/>
         </p:nvSpPr>
         <p:spPr>
           <a:xfrm>
-            <a:off x="731520" y="1463040"/>
-            <a:ext cx="5212080" cy="3657600"/>
+            <a:off x="731520" y="1645920"/>
+            <a:ext cx="5120640" cy="3291840"/>
           </a:xfrm>
           <a:prstGeom prst="roundRect">
             <a:avLst/>
@@ -5885,12 +5869,12 @@
             <a:pPr algn="ctr">
               <a:defRPr sz="1200" b="1">
                 <a:solidFill>
-                  <a:srgbClr val="0F766E"/>
-                </a:solidFill>
-              </a:defRPr>
-            </a:pPr>
-            <a:r>
-              <a:t>PHASE 1: SHORT-TERM ROADMAP (0 - 3 MONTHS)</a:t>
+                  <a:srgbClr val="0E7490"/>
+                </a:solidFill>
+              </a:defRPr>
+            </a:pPr>
+            <a:r>
+              <a:t>PHASE 1: SHORT-TERM ROADMAP</a:t>
             </a:r>
           </a:p>
           <a:p>
@@ -5902,7 +5886,7 @@
               </a:defRPr>
             </a:pPr>
             <a:r>
-              <a:t>▶ Automated Notification Engine: Instant email and SMS alerts upon submission, managerial review, or status change.</a:t>
+              <a:t>▶  Email &amp; SMS Alerts: Instant notification on application and review</a:t>
             </a:r>
           </a:p>
           <a:p>
@@ -5914,7 +5898,7 @@
               </a:defRPr>
             </a:pPr>
             <a:r>
-              <a:t>▶ Calendar Synchronization: Two-way integration with Google Calendar and Microsoft Outlook for automatic Out-Of-Office events.</a:t>
+              <a:t>▶  Calendar Integration: 2-way sync with Google Calendar &amp; Outlook</a:t>
             </a:r>
           </a:p>
           <a:p>
@@ -5926,7 +5910,7 @@
               </a:defRPr>
             </a:pPr>
             <a:r>
-              <a:t>▶ Granular Half-Day / Hourly Leaves: Support for half-day sessions and short-duration emergency permits.</a:t>
+              <a:t>▶  Half-Day Leaves: Support for half-day &amp; emergency short leaves</a:t>
             </a:r>
           </a:p>
           <a:p>
@@ -5938,21 +5922,21 @@
               </a:defRPr>
             </a:pPr>
             <a:r>
-              <a:t>▶ Audit Export &amp; Compliance Reports: One-click export of monthly department leave summaries to Excel / PDF.</a:t>
-            </a:r>
-          </a:p>
-        </p:txBody>
-      </p:sp>
-      <p:sp>
-        <p:nvSpPr>
-          <p:cNvPr id="5" name="Rounded Rectangle 4"/>
+              <a:t>▶  Export Reports: 1-click monthly leave summaries to Excel / PDF</a:t>
+            </a:r>
+          </a:p>
+        </p:txBody>
+      </p:sp>
+      <p:sp>
+        <p:nvSpPr>
+          <p:cNvPr id="6" name="Rounded Rectangle 5"/>
           <p:cNvSpPr/>
           <p:nvPr/>
         </p:nvSpPr>
         <p:spPr>
           <a:xfrm>
-            <a:off x="6217920" y="1463040"/>
-            <a:ext cx="5212080" cy="3657600"/>
+            <a:off x="6217920" y="1645920"/>
+            <a:ext cx="5212080" cy="3291840"/>
           </a:xfrm>
           <a:prstGeom prst="roundRect">
             <a:avLst/>
@@ -5987,12 +5971,12 @@
             <a:pPr algn="ctr">
               <a:defRPr sz="1200" b="1">
                 <a:solidFill>
-                  <a:srgbClr val="0F766E"/>
-                </a:solidFill>
-              </a:defRPr>
-            </a:pPr>
-            <a:r>
-              <a:t>PHASE 2: LONG-TERM VISION (3 - 12 MONTHS)</a:t>
+                  <a:srgbClr val="0E7490"/>
+                </a:solidFill>
+              </a:defRPr>
+            </a:pPr>
+            <a:r>
+              <a:t>PHASE 2: LONG-TERM VISION</a:t>
             </a:r>
           </a:p>
           <a:p>
@@ -6004,7 +5988,7 @@
               </a:defRPr>
             </a:pPr>
             <a:r>
-              <a:t>✦ AI-Powered Workload &amp; Risk Forecasting: Predictive intelligence alerting managers when departmental capacity drops below safety levels.</a:t>
+              <a:t>✦  AI Staffing Forecaster: Smart warnings when team capacity is too low</a:t>
             </a:r>
           </a:p>
           <a:p>
@@ -6016,7 +6000,7 @@
               </a:defRPr>
             </a:pPr>
             <a:r>
-              <a:t>✦ Dedicated Native Mobile Apps: Cross-platform iOS and Android mobile apps for quick thumb-tap approvals by on-the-move executives.</a:t>
+              <a:t>✦  Dedicated Mobile App: Quick approvals on Android and iOS devices</a:t>
             </a:r>
           </a:p>
           <a:p>
@@ -6028,7 +6012,7 @@
               </a:defRPr>
             </a:pPr>
             <a:r>
-              <a:t>✦ Biometric &amp; Hardware Attendance Sync: API bridge connecting physical biometric / RFID check-in devices with the cloud ledger.</a:t>
+              <a:t>✦  Biometric Attendance Sync: Connects directly with RFID &amp; biometric machines</a:t>
             </a:r>
           </a:p>
           <a:p>
@@ -6040,21 +6024,21 @@
               </a:defRPr>
             </a:pPr>
             <a:r>
-              <a:t>✦ Intelligent Slack &amp; MS Teams Bots: Apply for and approve leaves directly from workplace chat channels.</a:t>
-            </a:r>
-          </a:p>
-        </p:txBody>
-      </p:sp>
-      <p:sp>
-        <p:nvSpPr>
-          <p:cNvPr id="6" name="Rounded Rectangle 5"/>
+              <a:t>✦  Slack / Teams Integration: Request leaves directly inside chat channels</a:t>
+            </a:r>
+          </a:p>
+        </p:txBody>
+      </p:sp>
+      <p:sp>
+        <p:nvSpPr>
+          <p:cNvPr id="7" name="Rounded Rectangle 6"/>
           <p:cNvSpPr/>
           <p:nvPr/>
         </p:nvSpPr>
         <p:spPr>
           <a:xfrm>
-            <a:off x="731520" y="5303520"/>
-            <a:ext cx="10698480" cy="1097280"/>
+            <a:off x="731520" y="5120640"/>
+            <a:ext cx="10698480" cy="1188720"/>
           </a:xfrm>
           <a:prstGeom prst="roundRect">
             <a:avLst/>
@@ -6064,7 +6048,7 @@
           </a:solidFill>
           <a:ln>
             <a:solidFill>
-              <a:srgbClr val="0F766E"/>
+              <a:srgbClr val="0E7490"/>
             </a:solidFill>
           </a:ln>
         </p:spPr>
@@ -6089,24 +6073,24 @@
             <a:pPr algn="ctr">
               <a:defRPr sz="1100" b="1">
                 <a:solidFill>
-                  <a:srgbClr val="0F766E"/>
-                </a:solidFill>
-              </a:defRPr>
-            </a:pPr>
-            <a:r>
-              <a:t>CONCLUSION &amp; SUMMARY</a:t>
-            </a:r>
-          </a:p>
-          <a:p>
-            <a:pPr>
-              <a:defRPr sz="1000">
+                  <a:srgbClr val="0E7490"/>
+                </a:solidFill>
+              </a:defRPr>
+            </a:pPr>
+            <a:r>
+              <a:t>CONCLUSION</a:t>
+            </a:r>
+          </a:p>
+          <a:p>
+            <a:pPr>
+              <a:defRPr sz="1050">
                 <a:solidFill>
                   <a:srgbClr val="0F172A"/>
                 </a:solidFill>
               </a:defRPr>
             </a:pPr>
             <a:r>
-              <a:t>The Automated Employee Leave Management System transforms an inefficient, error-prone manual routine into an auditable, transparent, and seamless digital workflow—driving immediate productivity gains and workplace satisfaction.</a:t>
+              <a:t>Our Employee Leave Management System replaces messy, error-prone manual paperwork with a fast, transparent, and automated digital platform—delivering immediate clarity for employees and complete control for administrators.</a:t>
             </a:r>
           </a:p>
         </p:txBody>

</xml_diff>